<commit_message>
add Show direct user RBAC list for subscription and resource groups feature
</commit_message>
<xml_diff>
--- a/My Azure Extension.pptx
+++ b/My Azure Extension.pptx
@@ -11,7 +11,8 @@
     <p:sldId id="260" r:id="rId5"/>
     <p:sldId id="259" r:id="rId6"/>
     <p:sldId id="262" r:id="rId7"/>
-    <p:sldId id="261" r:id="rId8"/>
+    <p:sldId id="263" r:id="rId8"/>
+    <p:sldId id="261" r:id="rId9"/>
   </p:sldIdLst>
   <p:sldSz cx="12192000" cy="6858000"/>
   <p:notesSz cx="6858000" cy="9144000"/>
@@ -265,7 +266,7 @@
           <a:p>
             <a:fld id="{DD956615-4E69-4601-879E-C9C61DEA03B6}" type="datetimeFigureOut">
               <a:rPr lang="en-US" smtClean="0"/>
-              <a:t>7/9/2026</a:t>
+              <a:t>7/25/2026</a:t>
             </a:fld>
             <a:endParaRPr lang="en-US"/>
           </a:p>
@@ -463,7 +464,7 @@
           <a:p>
             <a:fld id="{DD956615-4E69-4601-879E-C9C61DEA03B6}" type="datetimeFigureOut">
               <a:rPr lang="en-US" smtClean="0"/>
-              <a:t>7/9/2026</a:t>
+              <a:t>7/25/2026</a:t>
             </a:fld>
             <a:endParaRPr lang="en-US"/>
           </a:p>
@@ -671,7 +672,7 @@
           <a:p>
             <a:fld id="{DD956615-4E69-4601-879E-C9C61DEA03B6}" type="datetimeFigureOut">
               <a:rPr lang="en-US" smtClean="0"/>
-              <a:t>7/9/2026</a:t>
+              <a:t>7/25/2026</a:t>
             </a:fld>
             <a:endParaRPr lang="en-US"/>
           </a:p>
@@ -869,7 +870,7 @@
           <a:p>
             <a:fld id="{DD956615-4E69-4601-879E-C9C61DEA03B6}" type="datetimeFigureOut">
               <a:rPr lang="en-US" smtClean="0"/>
-              <a:t>7/9/2026</a:t>
+              <a:t>7/25/2026</a:t>
             </a:fld>
             <a:endParaRPr lang="en-US"/>
           </a:p>
@@ -1144,7 +1145,7 @@
           <a:p>
             <a:fld id="{DD956615-4E69-4601-879E-C9C61DEA03B6}" type="datetimeFigureOut">
               <a:rPr lang="en-US" smtClean="0"/>
-              <a:t>7/9/2026</a:t>
+              <a:t>7/25/2026</a:t>
             </a:fld>
             <a:endParaRPr lang="en-US"/>
           </a:p>
@@ -1409,7 +1410,7 @@
           <a:p>
             <a:fld id="{DD956615-4E69-4601-879E-C9C61DEA03B6}" type="datetimeFigureOut">
               <a:rPr lang="en-US" smtClean="0"/>
-              <a:t>7/9/2026</a:t>
+              <a:t>7/25/2026</a:t>
             </a:fld>
             <a:endParaRPr lang="en-US"/>
           </a:p>
@@ -1821,7 +1822,7 @@
           <a:p>
             <a:fld id="{DD956615-4E69-4601-879E-C9C61DEA03B6}" type="datetimeFigureOut">
               <a:rPr lang="en-US" smtClean="0"/>
-              <a:t>7/9/2026</a:t>
+              <a:t>7/25/2026</a:t>
             </a:fld>
             <a:endParaRPr lang="en-US"/>
           </a:p>
@@ -1962,7 +1963,7 @@
           <a:p>
             <a:fld id="{DD956615-4E69-4601-879E-C9C61DEA03B6}" type="datetimeFigureOut">
               <a:rPr lang="en-US" smtClean="0"/>
-              <a:t>7/9/2026</a:t>
+              <a:t>7/25/2026</a:t>
             </a:fld>
             <a:endParaRPr lang="en-US"/>
           </a:p>
@@ -2075,7 +2076,7 @@
           <a:p>
             <a:fld id="{DD956615-4E69-4601-879E-C9C61DEA03B6}" type="datetimeFigureOut">
               <a:rPr lang="en-US" smtClean="0"/>
-              <a:t>7/9/2026</a:t>
+              <a:t>7/25/2026</a:t>
             </a:fld>
             <a:endParaRPr lang="en-US"/>
           </a:p>
@@ -2386,7 +2387,7 @@
           <a:p>
             <a:fld id="{DD956615-4E69-4601-879E-C9C61DEA03B6}" type="datetimeFigureOut">
               <a:rPr lang="en-US" smtClean="0"/>
-              <a:t>7/9/2026</a:t>
+              <a:t>7/25/2026</a:t>
             </a:fld>
             <a:endParaRPr lang="en-US"/>
           </a:p>
@@ -2674,7 +2675,7 @@
           <a:p>
             <a:fld id="{DD956615-4E69-4601-879E-C9C61DEA03B6}" type="datetimeFigureOut">
               <a:rPr lang="en-US" smtClean="0"/>
-              <a:t>7/9/2026</a:t>
+              <a:t>7/25/2026</a:t>
             </a:fld>
             <a:endParaRPr lang="en-US"/>
           </a:p>
@@ -2915,7 +2916,7 @@
           <a:p>
             <a:fld id="{DD956615-4E69-4601-879E-C9C61DEA03B6}" type="datetimeFigureOut">
               <a:rPr lang="en-US" smtClean="0"/>
-              <a:t>7/9/2026</a:t>
+              <a:t>7/25/2026</a:t>
             </a:fld>
             <a:endParaRPr lang="en-US"/>
           </a:p>
@@ -3472,6 +3473,36 @@
           </a:prstGeom>
         </p:spPr>
       </p:pic>
+      <p:pic>
+        <p:nvPicPr>
+          <p:cNvPr id="4" name="Picture 3">
+            <a:extLst>
+              <a:ext uri="{FF2B5EF4-FFF2-40B4-BE49-F238E27FC236}">
+                <a16:creationId xmlns:a16="http://schemas.microsoft.com/office/drawing/2014/main" id="{E7A50CB4-D7F1-A697-A3D9-881E09E0FC0C}"/>
+              </a:ext>
+            </a:extLst>
+          </p:cNvPr>
+          <p:cNvPicPr>
+            <a:picLocks noChangeAspect="1"/>
+          </p:cNvPicPr>
+          <p:nvPr/>
+        </p:nvPicPr>
+        <p:blipFill>
+          <a:blip r:embed="rId3"/>
+          <a:stretch>
+            <a:fillRect/>
+          </a:stretch>
+        </p:blipFill>
+        <p:spPr>
+          <a:xfrm>
+            <a:off x="7256213" y="-28682"/>
+            <a:ext cx="3572374" cy="5677692"/>
+          </a:xfrm>
+          <a:prstGeom prst="rect">
+            <a:avLst/>
+          </a:prstGeom>
+        </p:spPr>
+      </p:pic>
       <p:sp>
         <p:nvSpPr>
           <p:cNvPr id="6" name="Rectangle 5">
@@ -3486,8 +3517,8 @@
         </p:nvSpPr>
         <p:spPr>
           <a:xfrm>
-            <a:off x="6038850" y="0"/>
-            <a:ext cx="4711700" cy="1022350"/>
+            <a:off x="7389091" y="1208990"/>
+            <a:ext cx="3439496" cy="1691228"/>
           </a:xfrm>
           <a:prstGeom prst="rect">
             <a:avLst/>
@@ -3526,10 +3557,10 @@
       </p:sp>
       <p:sp>
         <p:nvSpPr>
-          <p:cNvPr id="2" name="Speech Bubble: Rectangle 1">
-            <a:extLst>
-              <a:ext uri="{FF2B5EF4-FFF2-40B4-BE49-F238E27FC236}">
-                <a16:creationId xmlns:a16="http://schemas.microsoft.com/office/drawing/2014/main" id="{AB62C5D2-3D80-4299-A136-6E7D5DE53E77}"/>
+          <p:cNvPr id="7" name="Rectangle 6">
+            <a:extLst>
+              <a:ext uri="{FF2B5EF4-FFF2-40B4-BE49-F238E27FC236}">
+                <a16:creationId xmlns:a16="http://schemas.microsoft.com/office/drawing/2014/main" id="{4DC68636-D51D-A331-737C-8DE3CB1B9086}"/>
               </a:ext>
             </a:extLst>
           </p:cNvPr>
@@ -3538,13 +3569,59 @@
         </p:nvSpPr>
         <p:spPr>
           <a:xfrm>
-            <a:off x="228600" y="883920"/>
-            <a:ext cx="5521960" cy="949960"/>
+            <a:off x="7620000" y="1958109"/>
+            <a:ext cx="2706255" cy="166255"/>
+          </a:xfrm>
+          <a:prstGeom prst="rect">
+            <a:avLst/>
+          </a:prstGeom>
+        </p:spPr>
+        <p:style>
+          <a:lnRef idx="2">
+            <a:schemeClr val="accent1">
+              <a:shade val="15000"/>
+            </a:schemeClr>
+          </a:lnRef>
+          <a:fillRef idx="1">
+            <a:schemeClr val="accent1"/>
+          </a:fillRef>
+          <a:effectRef idx="0">
+            <a:schemeClr val="accent1"/>
+          </a:effectRef>
+          <a:fontRef idx="minor">
+            <a:schemeClr val="lt1"/>
+          </a:fontRef>
+        </p:style>
+        <p:txBody>
+          <a:bodyPr rtlCol="0" anchor="ctr"/>
+          <a:lstStyle/>
+          <a:p>
+            <a:pPr algn="ctr"/>
+            <a:endParaRPr lang="en-US"/>
+          </a:p>
+        </p:txBody>
+      </p:sp>
+      <p:sp>
+        <p:nvSpPr>
+          <p:cNvPr id="2" name="Speech Bubble: Rectangle 1">
+            <a:extLst>
+              <a:ext uri="{FF2B5EF4-FFF2-40B4-BE49-F238E27FC236}">
+                <a16:creationId xmlns:a16="http://schemas.microsoft.com/office/drawing/2014/main" id="{AB62C5D2-3D80-4299-A136-6E7D5DE53E77}"/>
+              </a:ext>
+            </a:extLst>
+          </p:cNvPr>
+          <p:cNvSpPr/>
+          <p:nvPr/>
+        </p:nvSpPr>
+        <p:spPr>
+          <a:xfrm>
+            <a:off x="1734253" y="77815"/>
+            <a:ext cx="5521960" cy="4124729"/>
           </a:xfrm>
           <a:prstGeom prst="wedgeRectCallout">
             <a:avLst>
-              <a:gd name="adj1" fmla="val 40809"/>
-              <a:gd name="adj2" fmla="val -94262"/>
+              <a:gd name="adj1" fmla="val 53856"/>
+              <a:gd name="adj2" fmla="val -17903"/>
             </a:avLst>
           </a:prstGeom>
         </p:spPr>
@@ -3569,7 +3646,7 @@
             <a:pPr algn="ctr"/>
             <a:r>
               <a:rPr lang="en-US" sz="3200" dirty="0"/>
-              <a:t>Setup background image</a:t>
+              <a:t>Background image</a:t>
             </a:r>
           </a:p>
         </p:txBody>
@@ -3606,10 +3683,10 @@
       </p:grpSpPr>
       <p:pic>
         <p:nvPicPr>
-          <p:cNvPr id="5" name="Picture 4">
-            <a:extLst>
-              <a:ext uri="{FF2B5EF4-FFF2-40B4-BE49-F238E27FC236}">
-                <a16:creationId xmlns:a16="http://schemas.microsoft.com/office/drawing/2014/main" id="{0828F26B-46E4-421A-9986-3CB73BE70F4D}"/>
+          <p:cNvPr id="12" name="Picture 11">
+            <a:extLst>
+              <a:ext uri="{FF2B5EF4-FFF2-40B4-BE49-F238E27FC236}">
+                <a16:creationId xmlns:a16="http://schemas.microsoft.com/office/drawing/2014/main" id="{D3563561-FBA5-DF51-5ED2-F38549C4ABD0}"/>
               </a:ext>
             </a:extLst>
           </p:cNvPr>
@@ -3626,8 +3703,8 @@
         </p:blipFill>
         <p:spPr>
           <a:xfrm>
-            <a:off x="3362325" y="1855787"/>
-            <a:ext cx="5886450" cy="3057525"/>
+            <a:off x="6000713" y="302376"/>
+            <a:ext cx="5068007" cy="3200847"/>
           </a:xfrm>
           <a:prstGeom prst="rect">
             <a:avLst/>
@@ -3636,10 +3713,10 @@
       </p:pic>
       <p:pic>
         <p:nvPicPr>
-          <p:cNvPr id="7" name="Picture 6">
-            <a:extLst>
-              <a:ext uri="{FF2B5EF4-FFF2-40B4-BE49-F238E27FC236}">
-                <a16:creationId xmlns:a16="http://schemas.microsoft.com/office/drawing/2014/main" id="{CE2DBC61-8605-4A8C-91E5-BD87CC8A143F}"/>
+          <p:cNvPr id="8" name="Picture 7">
+            <a:extLst>
+              <a:ext uri="{FF2B5EF4-FFF2-40B4-BE49-F238E27FC236}">
+                <a16:creationId xmlns:a16="http://schemas.microsoft.com/office/drawing/2014/main" id="{05E6313B-176A-77F0-6FE3-0477799747E2}"/>
               </a:ext>
             </a:extLst>
           </p:cNvPr>
@@ -3656,44 +3733,14 @@
         </p:blipFill>
         <p:spPr>
           <a:xfrm>
-            <a:off x="2600325" y="771525"/>
-            <a:ext cx="6991350" cy="5314950"/>
+            <a:off x="2393122" y="302376"/>
+            <a:ext cx="3581900" cy="5772956"/>
           </a:xfrm>
           <a:prstGeom prst="rect">
             <a:avLst/>
           </a:prstGeom>
         </p:spPr>
       </p:pic>
-      <p:pic>
-        <p:nvPicPr>
-          <p:cNvPr id="9" name="Picture 8">
-            <a:extLst>
-              <a:ext uri="{FF2B5EF4-FFF2-40B4-BE49-F238E27FC236}">
-                <a16:creationId xmlns:a16="http://schemas.microsoft.com/office/drawing/2014/main" id="{A17833E4-1897-4767-AEAF-3C843FB36477}"/>
-              </a:ext>
-            </a:extLst>
-          </p:cNvPr>
-          <p:cNvPicPr>
-            <a:picLocks noChangeAspect="1"/>
-          </p:cNvPicPr>
-          <p:nvPr/>
-        </p:nvPicPr>
-        <p:blipFill>
-          <a:blip r:embed="rId4"/>
-          <a:stretch>
-            <a:fillRect/>
-          </a:stretch>
-        </p:blipFill>
-        <p:spPr>
-          <a:xfrm>
-            <a:off x="2600325" y="840996"/>
-            <a:ext cx="4924425" cy="4572000"/>
-          </a:xfrm>
-          <a:prstGeom prst="rect">
-            <a:avLst/>
-          </a:prstGeom>
-        </p:spPr>
-      </p:pic>
       <p:sp>
         <p:nvSpPr>
           <p:cNvPr id="11" name="Rectangle 10">
@@ -3708,8 +3755,8 @@
         </p:nvSpPr>
         <p:spPr>
           <a:xfrm>
-            <a:off x="2600325" y="3464560"/>
-            <a:ext cx="2169795" cy="1320800"/>
+            <a:off x="2461779" y="3279833"/>
+            <a:ext cx="3366366" cy="1781694"/>
           </a:xfrm>
           <a:prstGeom prst="rect">
             <a:avLst/>
@@ -3760,7 +3807,7 @@
         </p:nvSpPr>
         <p:spPr>
           <a:xfrm>
-            <a:off x="7477760" y="784604"/>
+            <a:off x="8954805" y="302376"/>
             <a:ext cx="2113915" cy="397704"/>
           </a:xfrm>
           <a:prstGeom prst="rect">
@@ -3812,7 +3859,7 @@
         </p:nvSpPr>
         <p:spPr>
           <a:xfrm>
-            <a:off x="3139440" y="1637158"/>
+            <a:off x="5143731" y="1221522"/>
             <a:ext cx="5521960" cy="949960"/>
           </a:xfrm>
           <a:prstGeom prst="wedgeRectCallout">
@@ -3850,7 +3897,7 @@
             <a:pPr algn="ctr"/>
             <a:r>
               <a:rPr lang="en-US" sz="3200" dirty="0"/>
-              <a:t>Azure AD tenant name</a:t>
+              <a:t>Entra ID tenant name</a:t>
             </a:r>
           </a:p>
         </p:txBody>
@@ -4352,10 +4399,10 @@
       </p:grpSpPr>
       <p:pic>
         <p:nvPicPr>
-          <p:cNvPr id="5" name="Picture 4">
-            <a:extLst>
-              <a:ext uri="{FF2B5EF4-FFF2-40B4-BE49-F238E27FC236}">
-                <a16:creationId xmlns:a16="http://schemas.microsoft.com/office/drawing/2014/main" id="{EFD62122-1E9B-A461-F9F4-1A9E7DFC6C06}"/>
+          <p:cNvPr id="3" name="Picture 2">
+            <a:extLst>
+              <a:ext uri="{FF2B5EF4-FFF2-40B4-BE49-F238E27FC236}">
+                <a16:creationId xmlns:a16="http://schemas.microsoft.com/office/drawing/2014/main" id="{4386F712-283E-CDC2-FF63-BE9347234A31}"/>
               </a:ext>
             </a:extLst>
           </p:cNvPr>
@@ -4372,8 +4419,8 @@
         </p:blipFill>
         <p:spPr>
           <a:xfrm>
-            <a:off x="3600101" y="585390"/>
-            <a:ext cx="4991797" cy="5687219"/>
+            <a:off x="4295523" y="580627"/>
+            <a:ext cx="3600953" cy="5696745"/>
           </a:xfrm>
           <a:prstGeom prst="rect">
             <a:avLst/>
@@ -4394,8 +4441,8 @@
         </p:nvSpPr>
         <p:spPr>
           <a:xfrm>
-            <a:off x="3600100" y="3965027"/>
-            <a:ext cx="4834451" cy="1931275"/>
+            <a:off x="4295523" y="3307771"/>
+            <a:ext cx="3379895" cy="2899065"/>
           </a:xfrm>
           <a:prstGeom prst="rect">
             <a:avLst/>
@@ -4446,7 +4493,7 @@
         </p:nvSpPr>
         <p:spPr>
           <a:xfrm>
-            <a:off x="4382814" y="4903076"/>
+            <a:off x="4687614" y="4653694"/>
             <a:ext cx="2151993" cy="134007"/>
           </a:xfrm>
           <a:prstGeom prst="rect">
@@ -4492,7 +4539,7 @@
         </p:nvSpPr>
         <p:spPr>
           <a:xfrm>
-            <a:off x="4382814" y="5256485"/>
+            <a:off x="4687613" y="5239046"/>
             <a:ext cx="2151993" cy="134007"/>
           </a:xfrm>
           <a:prstGeom prst="rect">
@@ -4538,7 +4585,7 @@
         </p:nvSpPr>
         <p:spPr>
           <a:xfrm>
-            <a:off x="4382813" y="4568057"/>
+            <a:off x="4687613" y="4063441"/>
             <a:ext cx="2151993" cy="134007"/>
           </a:xfrm>
           <a:prstGeom prst="rect">
@@ -4566,7 +4613,7 @@
           <a:lstStyle/>
           <a:p>
             <a:pPr algn="ctr"/>
-            <a:endParaRPr lang="en-US"/>
+            <a:endParaRPr lang="en-US" dirty="0"/>
           </a:p>
         </p:txBody>
       </p:sp>
@@ -4584,6 +4631,572 @@
 </file>
 
 <file path=ppt/slides/slide7.xml><?xml version="1.0" encoding="utf-8"?>
+<p:sld xmlns:a="http://schemas.openxmlformats.org/drawingml/2006/main" xmlns:r="http://schemas.openxmlformats.org/officeDocument/2006/relationships" xmlns:p="http://schemas.openxmlformats.org/presentationml/2006/main">
+  <p:cSld>
+    <p:spTree>
+      <p:nvGrpSpPr>
+        <p:cNvPr id="1" name=""/>
+        <p:cNvGrpSpPr/>
+        <p:nvPr/>
+      </p:nvGrpSpPr>
+      <p:grpSpPr>
+        <a:xfrm>
+          <a:off x="0" y="0"/>
+          <a:ext cx="0" cy="0"/>
+          <a:chOff x="0" y="0"/>
+          <a:chExt cx="0" cy="0"/>
+        </a:xfrm>
+      </p:grpSpPr>
+      <p:pic>
+        <p:nvPicPr>
+          <p:cNvPr id="5" name="Picture 4">
+            <a:extLst>
+              <a:ext uri="{FF2B5EF4-FFF2-40B4-BE49-F238E27FC236}">
+                <a16:creationId xmlns:a16="http://schemas.microsoft.com/office/drawing/2014/main" id="{68D03932-C0AC-D298-7E89-CE8BD615E5A3}"/>
+              </a:ext>
+            </a:extLst>
+          </p:cNvPr>
+          <p:cNvPicPr>
+            <a:picLocks noChangeAspect="1"/>
+          </p:cNvPicPr>
+          <p:nvPr/>
+        </p:nvPicPr>
+        <p:blipFill>
+          <a:blip r:embed="rId2"/>
+          <a:stretch>
+            <a:fillRect/>
+          </a:stretch>
+        </p:blipFill>
+        <p:spPr>
+          <a:xfrm>
+            <a:off x="2614126" y="409153"/>
+            <a:ext cx="6963747" cy="6039693"/>
+          </a:xfrm>
+          <a:prstGeom prst="rect">
+            <a:avLst/>
+          </a:prstGeom>
+        </p:spPr>
+      </p:pic>
+      <p:sp>
+        <p:nvSpPr>
+          <p:cNvPr id="7" name="Rectangle 6">
+            <a:extLst>
+              <a:ext uri="{FF2B5EF4-FFF2-40B4-BE49-F238E27FC236}">
+                <a16:creationId xmlns:a16="http://schemas.microsoft.com/office/drawing/2014/main" id="{7D3CCFFC-C383-AA78-D695-4263D2DDAC2C}"/>
+              </a:ext>
+            </a:extLst>
+          </p:cNvPr>
+          <p:cNvSpPr/>
+          <p:nvPr/>
+        </p:nvSpPr>
+        <p:spPr>
+          <a:xfrm>
+            <a:off x="6095999" y="1608999"/>
+            <a:ext cx="2151993" cy="134007"/>
+          </a:xfrm>
+          <a:prstGeom prst="rect">
+            <a:avLst/>
+          </a:prstGeom>
+        </p:spPr>
+        <p:style>
+          <a:lnRef idx="2">
+            <a:schemeClr val="accent2">
+              <a:shade val="15000"/>
+            </a:schemeClr>
+          </a:lnRef>
+          <a:fillRef idx="1">
+            <a:schemeClr val="accent2"/>
+          </a:fillRef>
+          <a:effectRef idx="0">
+            <a:schemeClr val="accent2"/>
+          </a:effectRef>
+          <a:fontRef idx="minor">
+            <a:schemeClr val="lt1"/>
+          </a:fontRef>
+        </p:style>
+        <p:txBody>
+          <a:bodyPr rtlCol="0" anchor="ctr"/>
+          <a:lstStyle/>
+          <a:p>
+            <a:pPr algn="ctr"/>
+            <a:endParaRPr lang="en-US" dirty="0"/>
+          </a:p>
+        </p:txBody>
+      </p:sp>
+      <p:sp>
+        <p:nvSpPr>
+          <p:cNvPr id="9" name="Rectangle 8">
+            <a:extLst>
+              <a:ext uri="{FF2B5EF4-FFF2-40B4-BE49-F238E27FC236}">
+                <a16:creationId xmlns:a16="http://schemas.microsoft.com/office/drawing/2014/main" id="{5195E67E-570B-6D26-B181-22FBEF3ED126}"/>
+              </a:ext>
+            </a:extLst>
+          </p:cNvPr>
+          <p:cNvSpPr/>
+          <p:nvPr/>
+        </p:nvSpPr>
+        <p:spPr>
+          <a:xfrm>
+            <a:off x="6801853" y="2322873"/>
+            <a:ext cx="1668380" cy="134007"/>
+          </a:xfrm>
+          <a:prstGeom prst="rect">
+            <a:avLst/>
+          </a:prstGeom>
+        </p:spPr>
+        <p:style>
+          <a:lnRef idx="2">
+            <a:schemeClr val="accent2">
+              <a:shade val="15000"/>
+            </a:schemeClr>
+          </a:lnRef>
+          <a:fillRef idx="1">
+            <a:schemeClr val="accent2"/>
+          </a:fillRef>
+          <a:effectRef idx="0">
+            <a:schemeClr val="accent2"/>
+          </a:effectRef>
+          <a:fontRef idx="minor">
+            <a:schemeClr val="lt1"/>
+          </a:fontRef>
+        </p:style>
+        <p:txBody>
+          <a:bodyPr rtlCol="0" anchor="ctr"/>
+          <a:lstStyle/>
+          <a:p>
+            <a:pPr algn="ctr"/>
+            <a:endParaRPr lang="en-US" dirty="0"/>
+          </a:p>
+        </p:txBody>
+      </p:sp>
+      <p:sp>
+        <p:nvSpPr>
+          <p:cNvPr id="11" name="Rectangle 10">
+            <a:extLst>
+              <a:ext uri="{FF2B5EF4-FFF2-40B4-BE49-F238E27FC236}">
+                <a16:creationId xmlns:a16="http://schemas.microsoft.com/office/drawing/2014/main" id="{22C4E748-44DD-1B6F-65C2-2A1224CD4370}"/>
+              </a:ext>
+            </a:extLst>
+          </p:cNvPr>
+          <p:cNvSpPr/>
+          <p:nvPr/>
+        </p:nvSpPr>
+        <p:spPr>
+          <a:xfrm>
+            <a:off x="6916498" y="2715904"/>
+            <a:ext cx="1668380" cy="134007"/>
+          </a:xfrm>
+          <a:prstGeom prst="rect">
+            <a:avLst/>
+          </a:prstGeom>
+        </p:spPr>
+        <p:style>
+          <a:lnRef idx="2">
+            <a:schemeClr val="accent2">
+              <a:shade val="15000"/>
+            </a:schemeClr>
+          </a:lnRef>
+          <a:fillRef idx="1">
+            <a:schemeClr val="accent2"/>
+          </a:fillRef>
+          <a:effectRef idx="0">
+            <a:schemeClr val="accent2"/>
+          </a:effectRef>
+          <a:fontRef idx="minor">
+            <a:schemeClr val="lt1"/>
+          </a:fontRef>
+        </p:style>
+        <p:txBody>
+          <a:bodyPr rtlCol="0" anchor="ctr"/>
+          <a:lstStyle/>
+          <a:p>
+            <a:pPr algn="ctr"/>
+            <a:endParaRPr lang="en-US" dirty="0"/>
+          </a:p>
+        </p:txBody>
+      </p:sp>
+      <p:sp>
+        <p:nvSpPr>
+          <p:cNvPr id="13" name="Rectangle 12">
+            <a:extLst>
+              <a:ext uri="{FF2B5EF4-FFF2-40B4-BE49-F238E27FC236}">
+                <a16:creationId xmlns:a16="http://schemas.microsoft.com/office/drawing/2014/main" id="{267413CA-CCA6-2DC0-6AF2-4F0A30FF814F}"/>
+              </a:ext>
+            </a:extLst>
+          </p:cNvPr>
+          <p:cNvSpPr/>
+          <p:nvPr/>
+        </p:nvSpPr>
+        <p:spPr>
+          <a:xfrm>
+            <a:off x="6801853" y="3103351"/>
+            <a:ext cx="1668380" cy="134007"/>
+          </a:xfrm>
+          <a:prstGeom prst="rect">
+            <a:avLst/>
+          </a:prstGeom>
+        </p:spPr>
+        <p:style>
+          <a:lnRef idx="2">
+            <a:schemeClr val="accent2">
+              <a:shade val="15000"/>
+            </a:schemeClr>
+          </a:lnRef>
+          <a:fillRef idx="1">
+            <a:schemeClr val="accent2"/>
+          </a:fillRef>
+          <a:effectRef idx="0">
+            <a:schemeClr val="accent2"/>
+          </a:effectRef>
+          <a:fontRef idx="minor">
+            <a:schemeClr val="lt1"/>
+          </a:fontRef>
+        </p:style>
+        <p:txBody>
+          <a:bodyPr rtlCol="0" anchor="ctr"/>
+          <a:lstStyle/>
+          <a:p>
+            <a:pPr algn="ctr"/>
+            <a:endParaRPr lang="en-US" dirty="0"/>
+          </a:p>
+        </p:txBody>
+      </p:sp>
+      <p:sp>
+        <p:nvSpPr>
+          <p:cNvPr id="15" name="Rectangle 14">
+            <a:extLst>
+              <a:ext uri="{FF2B5EF4-FFF2-40B4-BE49-F238E27FC236}">
+                <a16:creationId xmlns:a16="http://schemas.microsoft.com/office/drawing/2014/main" id="{FB536D0D-F6F1-A154-3AAE-3817243B76AA}"/>
+              </a:ext>
+            </a:extLst>
+          </p:cNvPr>
+          <p:cNvSpPr/>
+          <p:nvPr/>
+        </p:nvSpPr>
+        <p:spPr>
+          <a:xfrm>
+            <a:off x="6681537" y="3475470"/>
+            <a:ext cx="1668380" cy="134007"/>
+          </a:xfrm>
+          <a:prstGeom prst="rect">
+            <a:avLst/>
+          </a:prstGeom>
+        </p:spPr>
+        <p:style>
+          <a:lnRef idx="2">
+            <a:schemeClr val="accent2">
+              <a:shade val="15000"/>
+            </a:schemeClr>
+          </a:lnRef>
+          <a:fillRef idx="1">
+            <a:schemeClr val="accent2"/>
+          </a:fillRef>
+          <a:effectRef idx="0">
+            <a:schemeClr val="accent2"/>
+          </a:effectRef>
+          <a:fontRef idx="minor">
+            <a:schemeClr val="lt1"/>
+          </a:fontRef>
+        </p:style>
+        <p:txBody>
+          <a:bodyPr rtlCol="0" anchor="ctr"/>
+          <a:lstStyle/>
+          <a:p>
+            <a:pPr algn="ctr"/>
+            <a:endParaRPr lang="en-US" dirty="0"/>
+          </a:p>
+        </p:txBody>
+      </p:sp>
+      <p:sp>
+        <p:nvSpPr>
+          <p:cNvPr id="17" name="Rectangle 16">
+            <a:extLst>
+              <a:ext uri="{FF2B5EF4-FFF2-40B4-BE49-F238E27FC236}">
+                <a16:creationId xmlns:a16="http://schemas.microsoft.com/office/drawing/2014/main" id="{97F36EFD-B659-8A6C-2976-806CB84DAEB4}"/>
+              </a:ext>
+            </a:extLst>
+          </p:cNvPr>
+          <p:cNvSpPr/>
+          <p:nvPr/>
+        </p:nvSpPr>
+        <p:spPr>
+          <a:xfrm>
+            <a:off x="6681537" y="3894915"/>
+            <a:ext cx="1668380" cy="134007"/>
+          </a:xfrm>
+          <a:prstGeom prst="rect">
+            <a:avLst/>
+          </a:prstGeom>
+        </p:spPr>
+        <p:style>
+          <a:lnRef idx="2">
+            <a:schemeClr val="accent2">
+              <a:shade val="15000"/>
+            </a:schemeClr>
+          </a:lnRef>
+          <a:fillRef idx="1">
+            <a:schemeClr val="accent2"/>
+          </a:fillRef>
+          <a:effectRef idx="0">
+            <a:schemeClr val="accent2"/>
+          </a:effectRef>
+          <a:fontRef idx="minor">
+            <a:schemeClr val="lt1"/>
+          </a:fontRef>
+        </p:style>
+        <p:txBody>
+          <a:bodyPr rtlCol="0" anchor="ctr"/>
+          <a:lstStyle/>
+          <a:p>
+            <a:pPr algn="ctr"/>
+            <a:endParaRPr lang="en-US" dirty="0"/>
+          </a:p>
+        </p:txBody>
+      </p:sp>
+      <p:sp>
+        <p:nvSpPr>
+          <p:cNvPr id="19" name="Rectangle 18">
+            <a:extLst>
+              <a:ext uri="{FF2B5EF4-FFF2-40B4-BE49-F238E27FC236}">
+                <a16:creationId xmlns:a16="http://schemas.microsoft.com/office/drawing/2014/main" id="{15FCB042-481B-213F-91D6-C1C973CCACB2}"/>
+              </a:ext>
+            </a:extLst>
+          </p:cNvPr>
+          <p:cNvSpPr/>
+          <p:nvPr/>
+        </p:nvSpPr>
+        <p:spPr>
+          <a:xfrm>
+            <a:off x="6681537" y="4448368"/>
+            <a:ext cx="2654968" cy="134007"/>
+          </a:xfrm>
+          <a:prstGeom prst="rect">
+            <a:avLst/>
+          </a:prstGeom>
+        </p:spPr>
+        <p:style>
+          <a:lnRef idx="2">
+            <a:schemeClr val="accent2">
+              <a:shade val="15000"/>
+            </a:schemeClr>
+          </a:lnRef>
+          <a:fillRef idx="1">
+            <a:schemeClr val="accent2"/>
+          </a:fillRef>
+          <a:effectRef idx="0">
+            <a:schemeClr val="accent2"/>
+          </a:effectRef>
+          <a:fontRef idx="minor">
+            <a:schemeClr val="lt1"/>
+          </a:fontRef>
+        </p:style>
+        <p:txBody>
+          <a:bodyPr rtlCol="0" anchor="ctr"/>
+          <a:lstStyle/>
+          <a:p>
+            <a:pPr algn="ctr"/>
+            <a:endParaRPr lang="en-US" dirty="0"/>
+          </a:p>
+        </p:txBody>
+      </p:sp>
+      <p:sp>
+        <p:nvSpPr>
+          <p:cNvPr id="21" name="Rectangle 20">
+            <a:extLst>
+              <a:ext uri="{FF2B5EF4-FFF2-40B4-BE49-F238E27FC236}">
+                <a16:creationId xmlns:a16="http://schemas.microsoft.com/office/drawing/2014/main" id="{6FABFCEF-54E0-7BC5-EC10-3F9AD95AD44D}"/>
+              </a:ext>
+            </a:extLst>
+          </p:cNvPr>
+          <p:cNvSpPr/>
+          <p:nvPr/>
+        </p:nvSpPr>
+        <p:spPr>
+          <a:xfrm>
+            <a:off x="6681537" y="4835815"/>
+            <a:ext cx="2654968" cy="134007"/>
+          </a:xfrm>
+          <a:prstGeom prst="rect">
+            <a:avLst/>
+          </a:prstGeom>
+        </p:spPr>
+        <p:style>
+          <a:lnRef idx="2">
+            <a:schemeClr val="accent2">
+              <a:shade val="15000"/>
+            </a:schemeClr>
+          </a:lnRef>
+          <a:fillRef idx="1">
+            <a:schemeClr val="accent2"/>
+          </a:fillRef>
+          <a:effectRef idx="0">
+            <a:schemeClr val="accent2"/>
+          </a:effectRef>
+          <a:fontRef idx="minor">
+            <a:schemeClr val="lt1"/>
+          </a:fontRef>
+        </p:style>
+        <p:txBody>
+          <a:bodyPr rtlCol="0" anchor="ctr"/>
+          <a:lstStyle/>
+          <a:p>
+            <a:pPr algn="ctr"/>
+            <a:endParaRPr lang="en-US" dirty="0"/>
+          </a:p>
+        </p:txBody>
+      </p:sp>
+      <p:sp>
+        <p:nvSpPr>
+          <p:cNvPr id="23" name="Rectangle 22">
+            <a:extLst>
+              <a:ext uri="{FF2B5EF4-FFF2-40B4-BE49-F238E27FC236}">
+                <a16:creationId xmlns:a16="http://schemas.microsoft.com/office/drawing/2014/main" id="{9936A0C8-36D6-4A6F-9427-D8D5C5F2E849}"/>
+              </a:ext>
+            </a:extLst>
+          </p:cNvPr>
+          <p:cNvSpPr/>
+          <p:nvPr/>
+        </p:nvSpPr>
+        <p:spPr>
+          <a:xfrm>
+            <a:off x="6681537" y="5249001"/>
+            <a:ext cx="2654968" cy="134007"/>
+          </a:xfrm>
+          <a:prstGeom prst="rect">
+            <a:avLst/>
+          </a:prstGeom>
+        </p:spPr>
+        <p:style>
+          <a:lnRef idx="2">
+            <a:schemeClr val="accent2">
+              <a:shade val="15000"/>
+            </a:schemeClr>
+          </a:lnRef>
+          <a:fillRef idx="1">
+            <a:schemeClr val="accent2"/>
+          </a:fillRef>
+          <a:effectRef idx="0">
+            <a:schemeClr val="accent2"/>
+          </a:effectRef>
+          <a:fontRef idx="minor">
+            <a:schemeClr val="lt1"/>
+          </a:fontRef>
+        </p:style>
+        <p:txBody>
+          <a:bodyPr rtlCol="0" anchor="ctr"/>
+          <a:lstStyle/>
+          <a:p>
+            <a:pPr algn="ctr"/>
+            <a:endParaRPr lang="en-US" dirty="0"/>
+          </a:p>
+        </p:txBody>
+      </p:sp>
+      <p:sp>
+        <p:nvSpPr>
+          <p:cNvPr id="25" name="Rectangle 24">
+            <a:extLst>
+              <a:ext uri="{FF2B5EF4-FFF2-40B4-BE49-F238E27FC236}">
+                <a16:creationId xmlns:a16="http://schemas.microsoft.com/office/drawing/2014/main" id="{AA82D259-7054-45FC-68BA-0C797E5D331C}"/>
+              </a:ext>
+            </a:extLst>
+          </p:cNvPr>
+          <p:cNvSpPr/>
+          <p:nvPr/>
+        </p:nvSpPr>
+        <p:spPr>
+          <a:xfrm>
+            <a:off x="7395411" y="5595183"/>
+            <a:ext cx="1443789" cy="134007"/>
+          </a:xfrm>
+          <a:prstGeom prst="rect">
+            <a:avLst/>
+          </a:prstGeom>
+        </p:spPr>
+        <p:style>
+          <a:lnRef idx="2">
+            <a:schemeClr val="accent2">
+              <a:shade val="15000"/>
+            </a:schemeClr>
+          </a:lnRef>
+          <a:fillRef idx="1">
+            <a:schemeClr val="accent2"/>
+          </a:fillRef>
+          <a:effectRef idx="0">
+            <a:schemeClr val="accent2"/>
+          </a:effectRef>
+          <a:fontRef idx="minor">
+            <a:schemeClr val="lt1"/>
+          </a:fontRef>
+        </p:style>
+        <p:txBody>
+          <a:bodyPr rtlCol="0" anchor="ctr"/>
+          <a:lstStyle/>
+          <a:p>
+            <a:pPr algn="ctr"/>
+            <a:endParaRPr lang="en-US" dirty="0"/>
+          </a:p>
+        </p:txBody>
+      </p:sp>
+      <p:sp>
+        <p:nvSpPr>
+          <p:cNvPr id="27" name="Rectangle 26">
+            <a:extLst>
+              <a:ext uri="{FF2B5EF4-FFF2-40B4-BE49-F238E27FC236}">
+                <a16:creationId xmlns:a16="http://schemas.microsoft.com/office/drawing/2014/main" id="{4CC2FCFD-CD85-ABFA-C2B8-F0F23F35D20E}"/>
+              </a:ext>
+            </a:extLst>
+          </p:cNvPr>
+          <p:cNvSpPr/>
+          <p:nvPr/>
+        </p:nvSpPr>
+        <p:spPr>
+          <a:xfrm>
+            <a:off x="6565232" y="5807358"/>
+            <a:ext cx="2019646" cy="134007"/>
+          </a:xfrm>
+          <a:prstGeom prst="rect">
+            <a:avLst/>
+          </a:prstGeom>
+        </p:spPr>
+        <p:style>
+          <a:lnRef idx="2">
+            <a:schemeClr val="accent2">
+              <a:shade val="15000"/>
+            </a:schemeClr>
+          </a:lnRef>
+          <a:fillRef idx="1">
+            <a:schemeClr val="accent2"/>
+          </a:fillRef>
+          <a:effectRef idx="0">
+            <a:schemeClr val="accent2"/>
+          </a:effectRef>
+          <a:fontRef idx="minor">
+            <a:schemeClr val="lt1"/>
+          </a:fontRef>
+        </p:style>
+        <p:txBody>
+          <a:bodyPr rtlCol="0" anchor="ctr"/>
+          <a:lstStyle/>
+          <a:p>
+            <a:pPr algn="ctr"/>
+            <a:endParaRPr lang="en-US" dirty="0"/>
+          </a:p>
+        </p:txBody>
+      </p:sp>
+    </p:spTree>
+    <p:extLst>
+      <p:ext uri="{BB962C8B-B14F-4D97-AF65-F5344CB8AC3E}">
+        <p14:creationId xmlns:p14="http://schemas.microsoft.com/office/powerpoint/2010/main" val="1764195459"/>
+      </p:ext>
+    </p:extLst>
+  </p:cSld>
+  <p:clrMapOvr>
+    <a:masterClrMapping/>
+  </p:clrMapOvr>
+</p:sld>
+</file>
+
+<file path=ppt/slides/slide8.xml><?xml version="1.0" encoding="utf-8"?>
 <p:sld xmlns:a="http://schemas.openxmlformats.org/drawingml/2006/main" xmlns:r="http://schemas.openxmlformats.org/officeDocument/2006/relationships" xmlns:p="http://schemas.openxmlformats.org/presentationml/2006/main">
   <p:cSld>
     <p:spTree>

</xml_diff>